<commit_message>
docs: align README with v5 report, update presentation and technical reports
</commit_message>
<xml_diff>
--- a/presentation/Conways-Game-of-Life-CPU-vs-GPU-Presentation-Group-39.pptx
+++ b/presentation/Conways-Game-of-Life-CPU-vs-GPU-Presentation-Group-39.pptx
@@ -150,25 +150,17 @@
 </p:presentation>
 </file>
 
-<file path=ppt/revisionInfo.xml><?xml version="1.0" encoding="utf-8"?>
-<p1510:revInfo xmlns:a="http://schemas.openxmlformats.org/drawingml/2006/main" xmlns:r="http://schemas.openxmlformats.org/officeDocument/2006/relationships" xmlns:p1510="http://schemas.microsoft.com/office/powerpoint/2015/10/main">
-  <p1510:revLst>
-    <p1510:client id="{9C125297-43C2-43BA-B943-70416D8D6DE8}" v="153" dt="2026-10-12T17:02:01.967"/>
-  </p1510:revLst>
-</p1510:revInfo>
-</file>
-
 <file path=ppt/changesInfos/changesInfo1.xml><?xml version="1.0" encoding="utf-8"?>
 <pc:chgInfo xmlns:a="http://schemas.openxmlformats.org/drawingml/2006/main" xmlns:r="http://schemas.openxmlformats.org/officeDocument/2006/relationships" xmlns:ac="http://schemas.microsoft.com/office/drawing/2013/main/command" xmlns:pc="http://schemas.microsoft.com/office/powerpoint/2013/main/command">
   <pc:docChgLst>
     <pc:chgData name="NISAL SANJAYA" userId="f77bcb43de3b4771" providerId="LiveId" clId="{FD4A13A8-5E0E-412D-B8BB-0CFCCB5B6413}"/>
     <pc:docChg chg="undo custSel addSld delSld modSld modMainMaster modNotesMaster">
-      <pc:chgData name="NISAL SANJAYA" userId="f77bcb43de3b4771" providerId="LiveId" clId="{FD4A13A8-5E0E-412D-B8BB-0CFCCB5B6413}" dt="2026-10-12T17:13:34.980" v="234" actId="478"/>
+      <pc:chgData name="NISAL SANJAYA" userId="f77bcb43de3b4771" providerId="LiveId" clId="{FD4A13A8-5E0E-412D-B8BB-0CFCCB5B6413}" dt="2026-10-14T16:45:34.120" v="243" actId="34476"/>
       <pc:docMkLst>
         <pc:docMk/>
       </pc:docMkLst>
       <pc:sldChg chg="addSp delSp modSp add del mod modClrScheme modAnim chgLayout">
-        <pc:chgData name="NISAL SANJAYA" userId="f77bcb43de3b4771" providerId="LiveId" clId="{FD4A13A8-5E0E-412D-B8BB-0CFCCB5B6413}" dt="2026-10-12T17:08:18.890" v="232" actId="26606"/>
+        <pc:chgData name="NISAL SANJAYA" userId="f77bcb43de3b4771" providerId="LiveId" clId="{FD4A13A8-5E0E-412D-B8BB-0CFCCB5B6413}" dt="2026-10-14T16:42:06.203" v="238" actId="26606"/>
         <pc:sldMkLst>
           <pc:docMk/>
           <pc:sldMk cId="0" sldId="256"/>
@@ -190,7 +182,7 @@
           </ac:spMkLst>
         </pc:spChg>
         <pc:spChg chg="mod">
-          <ac:chgData name="NISAL SANJAYA" userId="f77bcb43de3b4771" providerId="LiveId" clId="{FD4A13A8-5E0E-412D-B8BB-0CFCCB5B6413}" dt="2026-10-12T16:18:44.966" v="206" actId="1076"/>
+          <ac:chgData name="NISAL SANJAYA" userId="f77bcb43de3b4771" providerId="LiveId" clId="{FD4A13A8-5E0E-412D-B8BB-0CFCCB5B6413}" dt="2026-10-14T16:42:06.203" v="238" actId="26606"/>
           <ac:spMkLst>
             <pc:docMk/>
             <pc:sldMk cId="0" sldId="256"/>
@@ -213,21 +205,21 @@
             <ac:picMk id="8" creationId="{2124482D-1214-CFBC-867A-6E5E51859F92}"/>
           </ac:picMkLst>
         </pc:picChg>
-        <pc:picChg chg="add del mod">
-          <ac:chgData name="NISAL SANJAYA" userId="f77bcb43de3b4771" providerId="LiveId" clId="{FD4A13A8-5E0E-412D-B8BB-0CFCCB5B6413}" dt="2026-10-12T16:36:09.840" v="208" actId="478"/>
-          <ac:picMkLst>
-            <pc:docMk/>
-            <pc:sldMk cId="0" sldId="256"/>
-            <ac:picMk id="10" creationId="{870411D4-7C44-D27B-5308-E65E38AAFF23}"/>
-          </ac:picMkLst>
-        </pc:picChg>
       </pc:sldChg>
-      <pc:sldChg chg="modSp add del mod modClrScheme chgLayout">
-        <pc:chgData name="NISAL SANJAYA" userId="f77bcb43de3b4771" providerId="LiveId" clId="{FD4A13A8-5E0E-412D-B8BB-0CFCCB5B6413}" dt="2026-10-12T15:59:30.574" v="11" actId="26606"/>
+      <pc:sldChg chg="modSp add del mod modClrScheme modShow chgLayout">
+        <pc:chgData name="NISAL SANJAYA" userId="f77bcb43de3b4771" providerId="LiveId" clId="{FD4A13A8-5E0E-412D-B8BB-0CFCCB5B6413}" dt="2026-10-14T16:43:18.226" v="241" actId="729"/>
         <pc:sldMkLst>
           <pc:docMk/>
           <pc:sldMk cId="0" sldId="257"/>
         </pc:sldMkLst>
+        <pc:spChg chg="mod">
+          <ac:chgData name="NISAL SANJAYA" userId="f77bcb43de3b4771" providerId="LiveId" clId="{FD4A13A8-5E0E-412D-B8BB-0CFCCB5B6413}" dt="2026-10-14T16:42:06.203" v="238" actId="26606"/>
+          <ac:spMkLst>
+            <pc:docMk/>
+            <pc:sldMk cId="0" sldId="257"/>
+            <ac:spMk id="5" creationId="{00000000-0000-0000-0000-000000000000}"/>
+          </ac:spMkLst>
+        </pc:spChg>
         <pc:picChg chg="mod">
           <ac:chgData name="NISAL SANJAYA" userId="f77bcb43de3b4771" providerId="LiveId" clId="{FD4A13A8-5E0E-412D-B8BB-0CFCCB5B6413}" dt="2026-10-11T22:08:53.925" v="6" actId="26606"/>
           <ac:picMkLst>
@@ -237,15 +229,15 @@
           </ac:picMkLst>
         </pc:picChg>
       </pc:sldChg>
-      <pc:sldChg chg="add del mod modClrScheme chgLayout">
-        <pc:chgData name="NISAL SANJAYA" userId="f77bcb43de3b4771" providerId="LiveId" clId="{FD4A13A8-5E0E-412D-B8BB-0CFCCB5B6413}" dt="2026-10-12T15:59:30.574" v="11" actId="26606"/>
+      <pc:sldChg chg="add del mod modClrScheme modShow chgLayout">
+        <pc:chgData name="NISAL SANJAYA" userId="f77bcb43de3b4771" providerId="LiveId" clId="{FD4A13A8-5E0E-412D-B8BB-0CFCCB5B6413}" dt="2026-10-14T16:43:18.226" v="241" actId="729"/>
         <pc:sldMkLst>
           <pc:docMk/>
           <pc:sldMk cId="0" sldId="258"/>
         </pc:sldMkLst>
       </pc:sldChg>
-      <pc:sldChg chg="modSp add del mod modClrScheme chgLayout">
-        <pc:chgData name="NISAL SANJAYA" userId="f77bcb43de3b4771" providerId="LiveId" clId="{FD4A13A8-5E0E-412D-B8BB-0CFCCB5B6413}" dt="2026-10-12T16:44:57.716" v="210" actId="26606"/>
+      <pc:sldChg chg="modSp add del mod modClrScheme modShow chgLayout">
+        <pc:chgData name="NISAL SANJAYA" userId="f77bcb43de3b4771" providerId="LiveId" clId="{FD4A13A8-5E0E-412D-B8BB-0CFCCB5B6413}" dt="2026-10-14T16:45:34.120" v="243" actId="34476"/>
         <pc:sldMkLst>
           <pc:docMk/>
           <pc:sldMk cId="0" sldId="259"/>
@@ -256,6 +248,14 @@
             <pc:docMk/>
             <pc:sldMk cId="0" sldId="259"/>
             <ac:spMk id="4" creationId="{00000000-0000-0000-0000-000000000000}"/>
+          </ac:spMkLst>
+        </pc:spChg>
+        <pc:spChg chg="mod">
+          <ac:chgData name="NISAL SANJAYA" userId="f77bcb43de3b4771" providerId="LiveId" clId="{FD4A13A8-5E0E-412D-B8BB-0CFCCB5B6413}" dt="2026-10-14T16:42:06.203" v="238" actId="26606"/>
+          <ac:spMkLst>
+            <pc:docMk/>
+            <pc:sldMk cId="0" sldId="259"/>
+            <ac:spMk id="16" creationId="{00000000-0000-0000-0000-000000000000}"/>
           </ac:spMkLst>
         </pc:spChg>
       </pc:sldChg>
@@ -336,22 +336,6 @@
             <ac:spMk id="11" creationId="{00000000-0000-0000-0000-000000000000}"/>
           </ac:spMkLst>
         </pc:spChg>
-        <pc:spChg chg="add del">
-          <ac:chgData name="NISAL SANJAYA" userId="f77bcb43de3b4771" providerId="LiveId" clId="{FD4A13A8-5E0E-412D-B8BB-0CFCCB5B6413}" dt="2026-10-12T17:13:34.980" v="234" actId="478"/>
-          <ac:spMkLst>
-            <pc:docMk/>
-            <pc:sldMk cId="0" sldId="261"/>
-            <ac:spMk id="14" creationId="{00000000-0000-0000-0000-000000000000}"/>
-          </ac:spMkLst>
-        </pc:spChg>
-        <pc:spChg chg="add del mod">
-          <ac:chgData name="NISAL SANJAYA" userId="f77bcb43de3b4771" providerId="LiveId" clId="{FD4A13A8-5E0E-412D-B8BB-0CFCCB5B6413}" dt="2026-10-12T17:04:19.525" v="223"/>
-          <ac:spMkLst>
-            <pc:docMk/>
-            <pc:sldMk cId="0" sldId="261"/>
-            <ac:spMk id="41" creationId="{00000000-0000-0000-0000-000000000000}"/>
-          </ac:spMkLst>
-        </pc:spChg>
         <pc:picChg chg="add mod">
           <ac:chgData name="NISAL SANJAYA" userId="f77bcb43de3b4771" providerId="LiveId" clId="{FD4A13A8-5E0E-412D-B8BB-0CFCCB5B6413}" dt="2026-10-12T17:04:18.817" v="221" actId="1076"/>
           <ac:picMkLst>
@@ -367,30 +351,6 @@
           <pc:docMk/>
           <pc:sldMk cId="0" sldId="262"/>
         </pc:sldMkLst>
-        <pc:spChg chg="add del">
-          <ac:chgData name="NISAL SANJAYA" userId="f77bcb43de3b4771" providerId="LiveId" clId="{FD4A13A8-5E0E-412D-B8BB-0CFCCB5B6413}" dt="2026-10-12T17:13:30.706" v="233" actId="478"/>
-          <ac:spMkLst>
-            <pc:docMk/>
-            <pc:sldMk cId="0" sldId="262"/>
-            <ac:spMk id="10" creationId="{00000000-0000-0000-0000-000000000000}"/>
-          </ac:spMkLst>
-        </pc:spChg>
-        <pc:spChg chg="add del mod">
-          <ac:chgData name="NISAL SANJAYA" userId="f77bcb43de3b4771" providerId="LiveId" clId="{FD4A13A8-5E0E-412D-B8BB-0CFCCB5B6413}" dt="2026-10-11T22:08:10.792" v="4"/>
-          <ac:spMkLst>
-            <pc:docMk/>
-            <pc:sldMk cId="0" sldId="262"/>
-            <ac:spMk id="10" creationId="{441F606F-F558-B1F1-E195-6213BAFDA189}"/>
-          </ac:spMkLst>
-        </pc:spChg>
-        <pc:spChg chg="add del mod">
-          <ac:chgData name="NISAL SANJAYA" userId="f77bcb43de3b4771" providerId="LiveId" clId="{FD4A13A8-5E0E-412D-B8BB-0CFCCB5B6413}" dt="2026-10-12T17:04:29.731" v="228"/>
-          <ac:spMkLst>
-            <pc:docMk/>
-            <pc:sldMk cId="0" sldId="262"/>
-            <ac:spMk id="29" creationId="{00000000-0000-0000-0000-000000000000}"/>
-          </ac:spMkLst>
-        </pc:spChg>
         <pc:spChg chg="add">
           <ac:chgData name="NISAL SANJAYA" userId="f77bcb43de3b4771" providerId="LiveId" clId="{FD4A13A8-5E0E-412D-B8BB-0CFCCB5B6413}" dt="2026-10-12T16:44:57.716" v="210" actId="26606"/>
           <ac:spMkLst>
@@ -480,26 +440,58 @@
         </pc:picChg>
       </pc:sldChg>
       <pc:sldChg chg="modSp add del mod modClrScheme chgLayout">
-        <pc:chgData name="NISAL SANJAYA" userId="f77bcb43de3b4771" providerId="LiveId" clId="{FD4A13A8-5E0E-412D-B8BB-0CFCCB5B6413}" dt="2026-10-12T17:08:18.890" v="232" actId="26606"/>
+        <pc:chgData name="NISAL SANJAYA" userId="f77bcb43de3b4771" providerId="LiveId" clId="{FD4A13A8-5E0E-412D-B8BB-0CFCCB5B6413}" dt="2026-10-14T16:42:06.203" v="238" actId="26606"/>
         <pc:sldMkLst>
           <pc:docMk/>
           <pc:sldMk cId="0" sldId="264"/>
         </pc:sldMkLst>
         <pc:spChg chg="mod">
-          <ac:chgData name="NISAL SANJAYA" userId="f77bcb43de3b4771" providerId="LiveId" clId="{FD4A13A8-5E0E-412D-B8BB-0CFCCB5B6413}" dt="2026-10-12T16:44:57.716" v="210" actId="26606"/>
+          <ac:chgData name="NISAL SANJAYA" userId="f77bcb43de3b4771" providerId="LiveId" clId="{FD4A13A8-5E0E-412D-B8BB-0CFCCB5B6413}" dt="2026-10-14T16:42:06.203" v="238" actId="26606"/>
+          <ac:spMkLst>
+            <pc:docMk/>
+            <pc:sldMk cId="0" sldId="264"/>
+            <ac:spMk id="2" creationId="{00000000-0000-0000-0000-000000000000}"/>
+          </ac:spMkLst>
+        </pc:spChg>
+        <pc:spChg chg="mod">
+          <ac:chgData name="NISAL SANJAYA" userId="f77bcb43de3b4771" providerId="LiveId" clId="{FD4A13A8-5E0E-412D-B8BB-0CFCCB5B6413}" dt="2026-10-14T16:42:06.203" v="238" actId="26606"/>
           <ac:spMkLst>
             <pc:docMk/>
             <pc:sldMk cId="0" sldId="264"/>
             <ac:spMk id="6" creationId="{00000000-0000-0000-0000-000000000000}"/>
           </ac:spMkLst>
         </pc:spChg>
+        <pc:spChg chg="mod">
+          <ac:chgData name="NISAL SANJAYA" userId="f77bcb43de3b4771" providerId="LiveId" clId="{FD4A13A8-5E0E-412D-B8BB-0CFCCB5B6413}" dt="2026-10-14T16:42:06.203" v="238" actId="26606"/>
+          <ac:spMkLst>
+            <pc:docMk/>
+            <pc:sldMk cId="0" sldId="264"/>
+            <ac:spMk id="7" creationId="{00000000-0000-0000-0000-000000000000}"/>
+          </ac:spMkLst>
+        </pc:spChg>
       </pc:sldChg>
       <pc:sldChg chg="modSp add del mod modClrScheme chgLayout">
-        <pc:chgData name="NISAL SANJAYA" userId="f77bcb43de3b4771" providerId="LiveId" clId="{FD4A13A8-5E0E-412D-B8BB-0CFCCB5B6413}" dt="2026-10-12T16:44:57.716" v="210" actId="26606"/>
+        <pc:chgData name="NISAL SANJAYA" userId="f77bcb43de3b4771" providerId="LiveId" clId="{FD4A13A8-5E0E-412D-B8BB-0CFCCB5B6413}" dt="2026-10-14T16:42:06.203" v="238" actId="26606"/>
         <pc:sldMkLst>
           <pc:docMk/>
           <pc:sldMk cId="0" sldId="265"/>
         </pc:sldMkLst>
+        <pc:spChg chg="mod">
+          <ac:chgData name="NISAL SANJAYA" userId="f77bcb43de3b4771" providerId="LiveId" clId="{FD4A13A8-5E0E-412D-B8BB-0CFCCB5B6413}" dt="2026-10-14T16:42:06.203" v="238" actId="26606"/>
+          <ac:spMkLst>
+            <pc:docMk/>
+            <pc:sldMk cId="0" sldId="265"/>
+            <ac:spMk id="5" creationId="{00000000-0000-0000-0000-000000000000}"/>
+          </ac:spMkLst>
+        </pc:spChg>
+        <pc:spChg chg="mod">
+          <ac:chgData name="NISAL SANJAYA" userId="f77bcb43de3b4771" providerId="LiveId" clId="{FD4A13A8-5E0E-412D-B8BB-0CFCCB5B6413}" dt="2026-10-14T16:42:06.203" v="238" actId="26606"/>
+          <ac:spMkLst>
+            <pc:docMk/>
+            <pc:sldMk cId="0" sldId="265"/>
+            <ac:spMk id="8" creationId="{00000000-0000-0000-0000-000000000000}"/>
+          </ac:spMkLst>
+        </pc:spChg>
         <pc:spChg chg="mod">
           <ac:chgData name="NISAL SANJAYA" userId="f77bcb43de3b4771" providerId="LiveId" clId="{FD4A13A8-5E0E-412D-B8BB-0CFCCB5B6413}" dt="2026-10-12T16:06:44.060" v="12" actId="20577"/>
           <ac:spMkLst>
@@ -509,8 +501,8 @@
           </ac:spMkLst>
         </pc:spChg>
       </pc:sldChg>
-      <pc:sldChg chg="modSp add mod">
-        <pc:chgData name="NISAL SANJAYA" userId="f77bcb43de3b4771" providerId="LiveId" clId="{FD4A13A8-5E0E-412D-B8BB-0CFCCB5B6413}" dt="2026-10-12T16:44:57.716" v="210" actId="26606"/>
+      <pc:sldChg chg="modSp add mod modShow">
+        <pc:chgData name="NISAL SANJAYA" userId="f77bcb43de3b4771" providerId="LiveId" clId="{FD4A13A8-5E0E-412D-B8BB-0CFCCB5B6413}" dt="2026-10-14T16:42:06.203" v="238" actId="26606"/>
         <pc:sldMkLst>
           <pc:docMk/>
           <pc:sldMk cId="0" sldId="266"/>
@@ -523,9 +515,17 @@
             <ac:spMk id="4" creationId="{00000000-0000-0000-0000-000000000000}"/>
           </ac:spMkLst>
         </pc:spChg>
+        <pc:spChg chg="mod">
+          <ac:chgData name="NISAL SANJAYA" userId="f77bcb43de3b4771" providerId="LiveId" clId="{FD4A13A8-5E0E-412D-B8BB-0CFCCB5B6413}" dt="2026-10-14T16:42:06.203" v="238" actId="26606"/>
+          <ac:spMkLst>
+            <pc:docMk/>
+            <pc:sldMk cId="0" sldId="266"/>
+            <ac:spMk id="16" creationId="{00000000-0000-0000-0000-000000000000}"/>
+          </ac:spMkLst>
+        </pc:spChg>
       </pc:sldChg>
-      <pc:sldChg chg="modSp add mod">
-        <pc:chgData name="NISAL SANJAYA" userId="f77bcb43de3b4771" providerId="LiveId" clId="{FD4A13A8-5E0E-412D-B8BB-0CFCCB5B6413}" dt="2026-10-12T16:44:57.716" v="210" actId="26606"/>
+      <pc:sldChg chg="modSp add mod modShow">
+        <pc:chgData name="NISAL SANJAYA" userId="f77bcb43de3b4771" providerId="LiveId" clId="{FD4A13A8-5E0E-412D-B8BB-0CFCCB5B6413}" dt="2026-10-14T16:45:34.120" v="243" actId="34476"/>
         <pc:sldMkLst>
           <pc:docMk/>
           <pc:sldMk cId="0" sldId="267"/>
@@ -538,20 +538,44 @@
             <ac:spMk id="4" creationId="{00000000-0000-0000-0000-000000000000}"/>
           </ac:spMkLst>
         </pc:spChg>
+        <pc:spChg chg="mod">
+          <ac:chgData name="NISAL SANJAYA" userId="f77bcb43de3b4771" providerId="LiveId" clId="{FD4A13A8-5E0E-412D-B8BB-0CFCCB5B6413}" dt="2026-10-14T16:42:06.203" v="238" actId="26606"/>
+          <ac:spMkLst>
+            <pc:docMk/>
+            <pc:sldMk cId="0" sldId="267"/>
+            <ac:spMk id="16" creationId="{00000000-0000-0000-0000-000000000000}"/>
+          </ac:spMkLst>
+        </pc:spChg>
       </pc:sldChg>
-      <pc:sldChg chg="add">
-        <pc:chgData name="NISAL SANJAYA" userId="f77bcb43de3b4771" providerId="LiveId" clId="{FD4A13A8-5E0E-412D-B8BB-0CFCCB5B6413}" dt="2026-10-12T16:44:57.716" v="210" actId="26606"/>
+      <pc:sldChg chg="modSp add mod">
+        <pc:chgData name="NISAL SANJAYA" userId="f77bcb43de3b4771" providerId="LiveId" clId="{FD4A13A8-5E0E-412D-B8BB-0CFCCB5B6413}" dt="2026-10-14T16:42:06.203" v="238" actId="26606"/>
         <pc:sldMkLst>
           <pc:docMk/>
           <pc:sldMk cId="0" sldId="268"/>
         </pc:sldMkLst>
+        <pc:spChg chg="mod">
+          <ac:chgData name="NISAL SANJAYA" userId="f77bcb43de3b4771" providerId="LiveId" clId="{FD4A13A8-5E0E-412D-B8BB-0CFCCB5B6413}" dt="2026-10-14T16:42:06.203" v="238" actId="26606"/>
+          <ac:spMkLst>
+            <pc:docMk/>
+            <pc:sldMk cId="0" sldId="268"/>
+            <ac:spMk id="14" creationId="{00000000-0000-0000-0000-000000000000}"/>
+          </ac:spMkLst>
+        </pc:spChg>
       </pc:sldChg>
-      <pc:sldChg chg="add">
-        <pc:chgData name="NISAL SANJAYA" userId="f77bcb43de3b4771" providerId="LiveId" clId="{FD4A13A8-5E0E-412D-B8BB-0CFCCB5B6413}" dt="2026-10-12T16:44:57.716" v="210" actId="26606"/>
+      <pc:sldChg chg="modSp add mod">
+        <pc:chgData name="NISAL SANJAYA" userId="f77bcb43de3b4771" providerId="LiveId" clId="{FD4A13A8-5E0E-412D-B8BB-0CFCCB5B6413}" dt="2026-10-14T16:42:06.203" v="238" actId="26606"/>
         <pc:sldMkLst>
           <pc:docMk/>
           <pc:sldMk cId="0" sldId="269"/>
         </pc:sldMkLst>
+        <pc:graphicFrameChg chg="mod modGraphic">
+          <ac:chgData name="NISAL SANJAYA" userId="f77bcb43de3b4771" providerId="LiveId" clId="{FD4A13A8-5E0E-412D-B8BB-0CFCCB5B6413}" dt="2026-10-14T16:42:06.203" v="238" actId="26606"/>
+          <ac:graphicFrameMkLst>
+            <pc:docMk/>
+            <pc:sldMk cId="0" sldId="269"/>
+            <ac:graphicFrameMk id="5" creationId="{00000000-0000-0000-0000-000000000000}"/>
+          </ac:graphicFrameMkLst>
+        </pc:graphicFrameChg>
       </pc:sldChg>
       <pc:sldMasterChg chg="addSldLayout delSldLayout modSldLayout">
         <pc:chgData name="NISAL SANJAYA" userId="f77bcb43de3b4771" providerId="LiveId" clId="{FD4A13A8-5E0E-412D-B8BB-0CFCCB5B6413}" dt="2026-10-11T22:08:53.925" v="6" actId="26606"/>
@@ -565,14 +589,6 @@
             <pc:docMk/>
             <pc:sldMasterMk cId="0" sldId="2147483648"/>
             <pc:sldLayoutMk cId="0" sldId="2147483650"/>
-          </pc:sldLayoutMkLst>
-        </pc:sldLayoutChg>
-        <pc:sldLayoutChg chg="del replId">
-          <pc:chgData name="NISAL SANJAYA" userId="f77bcb43de3b4771" providerId="LiveId" clId="{FD4A13A8-5E0E-412D-B8BB-0CFCCB5B6413}" dt="2026-10-11T22:08:53.925" v="6" actId="26606"/>
-          <pc:sldLayoutMkLst>
-            <pc:docMk/>
-            <pc:sldMasterMk cId="0" sldId="2147483648"/>
-            <pc:sldLayoutMk cId="0" sldId="2147483651"/>
           </pc:sldLayoutMkLst>
         </pc:sldLayoutChg>
       </pc:sldMasterChg>
@@ -606,7 +622,7 @@
     </p:spTree>
     <p:extLst>
       <p:ext uri="{BB962C8B-B14F-4D97-AF65-F5344CB8AC3E}">
-        <p14:creationId xmlns:p14="http://schemas.microsoft.com/office/powerpoint/2010/main" val="2462893264"/>
+        <p14:creationId xmlns:p14="http://schemas.microsoft.com/office/powerpoint/2010/main" val="527268660"/>
       </p:ext>
     </p:extLst>
   </p:cSld>
@@ -2400,7 +2416,7 @@
               <a:rPr lang="en-US" sz="1600" err="1">
                 <a:latin typeface="Manrope" panose="020B0604020202020204" charset="0"/>
               </a:rPr>
-              <a:t>M.D.S.H.Edirisinghe</a:t>
+              <a:t>M.D.S.H. Edirisinghe</a:t>
             </a:r>
             <a:r>
               <a:rPr lang="en-US" sz="1600">
@@ -2538,13 +2554,13 @@
   <p:clrMapOvr>
     <a:masterClrMapping/>
   </p:clrMapOvr>
-  <mc:AlternateContent xmlns:mc="http://schemas.openxmlformats.org/markup-compatibility/2006">
-    <mc:Choice xmlns:p14="http://schemas.microsoft.com/office/powerpoint/2010/main" Requires="p14">
+  <mc:AlternateContent xmlns:mc="http://schemas.openxmlformats.org/markup-compatibility/2006" xmlns:p14="http://schemas.microsoft.com/office/powerpoint/2010/main">
+    <mc:Choice Requires="p14">
       <p:transition p14:dur="300">
         <p:fade/>
       </p:transition>
     </mc:Choice>
-    <mc:Fallback>
+    <mc:Fallback xmlns="">
       <p:transition>
         <p:fade/>
       </p:transition>
@@ -4909,13 +4925,13 @@
   <p:clrMapOvr>
     <a:masterClrMapping/>
   </p:clrMapOvr>
-  <mc:AlternateContent xmlns:mc="http://schemas.openxmlformats.org/markup-compatibility/2006">
-    <mc:Choice xmlns:p14="http://schemas.microsoft.com/office/powerpoint/2010/main" Requires="p14">
+  <mc:AlternateContent xmlns:mc="http://schemas.openxmlformats.org/markup-compatibility/2006" xmlns:p14="http://schemas.microsoft.com/office/powerpoint/2010/main">
+    <mc:Choice Requires="p14">
       <p:transition p14:dur="300">
         <p:fade/>
       </p:transition>
     </mc:Choice>
-    <mc:Fallback>
+    <mc:Fallback xmlns="">
       <p:transition>
         <p:fade/>
       </p:transition>
@@ -5389,7 +5405,7 @@
                 <a:ea typeface="Space Grotesk Bold" pitchFamily="34" charset="-122"/>
                 <a:cs typeface="Space Grotesk Bold" pitchFamily="34" charset="-120"/>
               </a:rPr>
-              <a:t>08 · The optimisation surprise</a:t>
+              <a:t>08 · The optimization surprise</a:t>
             </a:r>
             <a:endParaRPr lang="en-US" sz="2900"/>
           </a:p>
@@ -5678,7 +5694,7 @@
                 <a:ea typeface="Manrope" pitchFamily="34" charset="-122"/>
                 <a:cs typeface="Manrope" pitchFamily="34" charset="-120"/>
               </a:rPr>
-              <a:t>Likely reason: the T4's L1/L2 caches already serve most repeated neighbour reads</a:t>
+              <a:t>Likely reason: the T4's L1/L2 caches already serve most repeated neighbor reads</a:t>
             </a:r>
             <a:endParaRPr lang="en-US" sz="2000"/>
           </a:p>
@@ -5701,7 +5717,7 @@
                 <a:ea typeface="Manrope" pitchFamily="34" charset="-122"/>
                 <a:cs typeface="Manrope" pitchFamily="34" charset="-120"/>
               </a:rPr>
-              <a:t>Halo loading (integer division and modulo), a synchronisation barrier, and extra shared-memory accesses add overhead</a:t>
+              <a:t>Halo loading (integer division and modulo), a synchronization barrier, and extra shared-memory accesses add overhead</a:t>
             </a:r>
             <a:endParaRPr lang="en-US" sz="2000"/>
           </a:p>
@@ -5745,7 +5761,7 @@
                 <a:ea typeface="Manrope" pitchFamily="34" charset="-122"/>
                 <a:cs typeface="Manrope" pitchFamily="34" charset="-120"/>
               </a:rPr>
-              <a:t>Always measure an optimisation</a:t>
+              <a:t>Always measure an optimization</a:t>
             </a:r>
             <a:endParaRPr lang="en-US" sz="2000"/>
           </a:p>
@@ -5798,13 +5814,13 @@
   <p:clrMapOvr>
     <a:masterClrMapping/>
   </p:clrMapOvr>
-  <mc:AlternateContent xmlns:mc="http://schemas.openxmlformats.org/markup-compatibility/2006">
-    <mc:Choice xmlns:p14="http://schemas.microsoft.com/office/powerpoint/2010/main" Requires="p14">
+  <mc:AlternateContent xmlns:mc="http://schemas.openxmlformats.org/markup-compatibility/2006" xmlns:p14="http://schemas.microsoft.com/office/powerpoint/2010/main">
+    <mc:Choice Requires="p14">
       <p:transition p14:dur="300">
         <p:fade/>
       </p:transition>
     </mc:Choice>
-    <mc:Fallback>
+    <mc:Fallback xmlns="">
       <p:transition>
         <p:fade/>
       </p:transition>
@@ -6753,7 +6769,7 @@
         <p:spPr>
           <a:xfrm>
             <a:off x="609904" y="5074920"/>
-            <a:ext cx="10972800" cy="1005840"/>
+            <a:ext cx="10972800" cy="923330"/>
           </a:xfrm>
           <a:prstGeom prst="rect">
             <a:avLst/>
@@ -6767,13 +6783,22 @@
           <a:lstStyle/>
           <a:p>
             <a:r>
+              <a:rPr lang="en-US" sz="2000" b="0">
+                <a:solidFill>
+                  <a:srgbClr val="26364A"/>
+                </a:solidFill>
+                <a:latin typeface="Manrope"/>
+              </a:rPr>
+              <a:t>Does not appear to be</a:t>
+            </a:r>
+            <a:r>
               <a:rPr sz="2000" b="0">
                 <a:solidFill>
                   <a:srgbClr val="26364A"/>
                 </a:solidFill>
                 <a:latin typeface="Manrope"/>
               </a:rPr>
-              <a:t>Not memory-bandwidth bound. Each thread does 9 one-byte loads, a store and index arithmetic, so instructions per cell are the likelier limit. This is why bit-packing is the next step.</a:t>
+              <a:t> memory-bandwidth bound. Each thread does 9 one-byte loads, a store and index arithmetic, so instructions per cell are the likelier limit. This is why bit-packing is the next step.</a:t>
             </a:r>
           </a:p>
         </p:txBody>
@@ -6783,13 +6808,13 @@
   <p:clrMapOvr>
     <a:masterClrMapping/>
   </p:clrMapOvr>
-  <mc:AlternateContent xmlns:mc="http://schemas.openxmlformats.org/markup-compatibility/2006">
-    <mc:Choice xmlns:p14="http://schemas.microsoft.com/office/powerpoint/2010/main" Requires="p14">
+  <mc:AlternateContent xmlns:mc="http://schemas.openxmlformats.org/markup-compatibility/2006" xmlns:p14="http://schemas.microsoft.com/office/powerpoint/2010/main">
+    <mc:Choice Requires="p14">
       <p:transition p14:dur="300">
         <p:fade/>
       </p:transition>
     </mc:Choice>
-    <mc:Fallback>
+    <mc:Fallback xmlns="">
       <p:transition>
         <p:fade/>
       </p:transition>
@@ -6934,7 +6959,13 @@
           <p:cNvGraphicFramePr>
             <a:graphicFrameLocks noGrp="1"/>
           </p:cNvGraphicFramePr>
-          <p:nvPr/>
+          <p:nvPr>
+            <p:extLst>
+              <p:ext uri="{D42A27DB-BD31-4B8C-83A1-F6EECF244321}">
+                <p14:modId xmlns:p14="http://schemas.microsoft.com/office/powerpoint/2010/main" val="3709995928"/>
+              </p:ext>
+            </p:extLst>
+          </p:nvPr>
         </p:nvGraphicFramePr>
         <p:xfrm>
           <a:off x="609904" y="1554480"/>
@@ -7508,16 +7539,16 @@
                         </a:spcAft>
                       </a:pPr>
                       <a:r>
-                        <a:rPr sz="1450" b="1">
+                        <a:rPr lang="en-US" sz="1450" b="1">
                           <a:solidFill>
                             <a:srgbClr val="26364A"/>
                           </a:solidFill>
                           <a:latin typeface="Manrope"/>
                         </a:rPr>
-                        <a:t>Synchronisation: </a:t>
+                        <a:t>Synchronization: </a:t>
                       </a:r>
                       <a:r>
-                        <a:rPr sz="1450">
+                        <a:rPr lang="en-US" sz="1450">
                           <a:solidFill>
                             <a:srgbClr val="26364A"/>
                           </a:solidFill>
@@ -7863,13 +7894,13 @@
   <p:clrMapOvr>
     <a:masterClrMapping/>
   </p:clrMapOvr>
-  <mc:AlternateContent xmlns:mc="http://schemas.openxmlformats.org/markup-compatibility/2006">
-    <mc:Choice xmlns:p14="http://schemas.microsoft.com/office/powerpoint/2010/main" Requires="p14">
+  <mc:AlternateContent xmlns:mc="http://schemas.openxmlformats.org/markup-compatibility/2006" xmlns:p14="http://schemas.microsoft.com/office/powerpoint/2010/main">
+    <mc:Choice Requires="p14">
       <p:transition p14:dur="300">
         <p:fade/>
       </p:transition>
     </mc:Choice>
-    <mc:Fallback>
+    <mc:Fallback xmlns="">
       <p:transition>
         <p:fade/>
       </p:transition>
@@ -8037,7 +8068,7 @@
                 <a:ea typeface="Manrope" pitchFamily="34" charset="-122"/>
                 <a:cs typeface="Manrope" pitchFamily="34" charset="-120"/>
               </a:rPr>
-              <a:t>Thread-per-cell parallelism, coalesced reads and device-resident data explain the gain</a:t>
+              <a:t>Thread-per-cell parallelism, coalesced reads and device-resident data are the techniques behind the gain</a:t>
             </a:r>
             <a:endParaRPr lang="en-US" sz="2000"/>
           </a:p>
@@ -8228,7 +8259,7 @@
                 <a:ea typeface="Manrope" pitchFamily="34" charset="-122"/>
                 <a:cs typeface="Manrope" pitchFamily="34" charset="-120"/>
               </a:rPr>
-              <a:t>Next: bit-packing, multi-threaded CPU baseline, larger grids</a:t>
+              <a:t>Next: bit-packing, multi-threaded CPU baseline</a:t>
             </a:r>
             <a:endParaRPr lang="en-US" sz="2000"/>
           </a:p>
@@ -8314,13 +8345,13 @@
   <p:clrMapOvr>
     <a:masterClrMapping/>
   </p:clrMapOvr>
-  <mc:AlternateContent xmlns:mc="http://schemas.openxmlformats.org/markup-compatibility/2006">
-    <mc:Choice xmlns:p14="http://schemas.microsoft.com/office/powerpoint/2010/main" Requires="p14">
+  <mc:AlternateContent xmlns:mc="http://schemas.openxmlformats.org/markup-compatibility/2006" xmlns:p14="http://schemas.microsoft.com/office/powerpoint/2010/main">
+    <mc:Choice Requires="p14">
       <p:transition p14:dur="300">
         <p:fade/>
       </p:transition>
     </mc:Choice>
-    <mc:Fallback>
+    <mc:Fallback xmlns="">
       <p:transition>
         <p:fade/>
       </p:transition>
@@ -8872,7 +8903,7 @@
                 <a:ea typeface="Manrope Bold" pitchFamily="34" charset="-122"/>
                 <a:cs typeface="Manrope Bold" pitchFamily="34" charset="-120"/>
               </a:rPr>
-              <a:t>8 neighbours</a:t>
+              <a:t>8 neighbors</a:t>
             </a:r>
             <a:r>
               <a:rPr lang="en-US" sz="2400">
@@ -11279,7 +11310,7 @@
                 <a:ea typeface="Manrope" pitchFamily="34" charset="-122"/>
                 <a:cs typeface="Manrope" pitchFamily="34" charset="-120"/>
               </a:rPr>
-              <a:t>Wrap-around neighbours preserve the toroidal grid</a:t>
+              <a:t>Wrap-around neighbors preserve the toroidal grid</a:t>
             </a:r>
             <a:endParaRPr lang="en-US" sz="2000"/>
           </a:p>
@@ -11376,13 +11407,13 @@
   <p:clrMapOvr>
     <a:masterClrMapping/>
   </p:clrMapOvr>
-  <mc:AlternateContent xmlns:mc="http://schemas.openxmlformats.org/markup-compatibility/2006" xmlns:p14="http://schemas.microsoft.com/office/powerpoint/2010/main">
-    <mc:Choice Requires="p14">
+  <mc:AlternateContent xmlns:mc="http://schemas.openxmlformats.org/markup-compatibility/2006">
+    <mc:Choice xmlns:p14="http://schemas.microsoft.com/office/powerpoint/2010/main" Requires="p14">
       <p:transition p14:dur="300">
         <p:fade/>
       </p:transition>
     </mc:Choice>
-    <mc:Fallback xmlns="">
+    <mc:Fallback>
       <p:transition>
         <p:fade/>
       </p:transition>
@@ -12637,7 +12668,7 @@
                 <a:ea typeface="Manrope" pitchFamily="34" charset="-122"/>
                 <a:cs typeface="Manrope" pitchFamily="34" charset="-120"/>
               </a:rPr>
-              <a:t>Wrap-around neighbours preserve the toroidal grid</a:t>
+              <a:t>Wrap-around neighbors preserve the toroidal grid</a:t>
             </a:r>
             <a:endParaRPr lang="en-US" sz="2000"/>
           </a:p>
@@ -13330,7 +13361,7 @@
                 <a:ea typeface="Manrope" pitchFamily="34" charset="-122"/>
                 <a:cs typeface="Manrope" pitchFamily="34" charset="-120"/>
               </a:rPr>
-              <a:t>Wrap-around neighbours preserve the toroidal grid</a:t>
+              <a:t>Wrap-around neighbors preserve the toroidal grid</a:t>
             </a:r>
             <a:endParaRPr lang="en-US" sz="2000"/>
           </a:p>
@@ -13427,13 +13458,13 @@
   <p:clrMapOvr>
     <a:masterClrMapping/>
   </p:clrMapOvr>
-  <mc:AlternateContent xmlns:mc="http://schemas.openxmlformats.org/markup-compatibility/2006" xmlns:p159="http://schemas.microsoft.com/office/powerpoint/2015/09/main">
-    <mc:Choice Requires="p159">
+  <mc:AlternateContent xmlns:mc="http://schemas.openxmlformats.org/markup-compatibility/2006">
+    <mc:Choice xmlns:p159="http://schemas.microsoft.com/office/powerpoint/2015/09/main" Requires="p159">
       <p:transition xmlns:p14="http://schemas.microsoft.com/office/powerpoint/2010/main" spd="slow" p14:dur="1100">
         <p159:morph option="byObject"/>
       </p:transition>
     </mc:Choice>
-    <mc:Fallback xmlns="">
+    <mc:Fallback>
       <p:transition spd="slow">
         <p:fade/>
       </p:transition>
@@ -14813,13 +14844,13 @@
   <p:clrMapOvr>
     <a:masterClrMapping/>
   </p:clrMapOvr>
-  <mc:AlternateContent xmlns:mc="http://schemas.openxmlformats.org/markup-compatibility/2006">
-    <mc:Choice xmlns:p14="http://schemas.microsoft.com/office/powerpoint/2010/main" Requires="p14">
+  <mc:AlternateContent xmlns:mc="http://schemas.openxmlformats.org/markup-compatibility/2006" xmlns:p14="http://schemas.microsoft.com/office/powerpoint/2010/main">
+    <mc:Choice Requires="p14">
       <p:transition p14:dur="300">
         <p:fade/>
       </p:transition>
     </mc:Choice>
-    <mc:Fallback>
+    <mc:Fallback xmlns="">
       <p:transition>
         <p:fade/>
       </p:transition>
@@ -16844,13 +16875,13 @@
   <p:clrMapOvr>
     <a:masterClrMapping/>
   </p:clrMapOvr>
-  <mc:AlternateContent xmlns:mc="http://schemas.openxmlformats.org/markup-compatibility/2006">
-    <mc:Choice xmlns:p14="http://schemas.microsoft.com/office/powerpoint/2010/main" Requires="p14">
+  <mc:AlternateContent xmlns:mc="http://schemas.openxmlformats.org/markup-compatibility/2006" xmlns:p14="http://schemas.microsoft.com/office/powerpoint/2010/main">
+    <mc:Choice Requires="p14">
       <p:transition p14:dur="300">
         <p:fade/>
       </p:transition>
     </mc:Choice>
-    <mc:Fallback>
+    <mc:Fallback xmlns="">
       <p:transition>
         <p:fade/>
       </p:transition>

</xml_diff>